<commit_message>
PPT v2 : chiffres audités (satisfaction ouvriers, #1 Mountain daté Q4, pub 35→80 vérifiée, bandeau slide 6 corrigé)
Co-Authored-By: Claude Fable 5 <noreply@anthropic.com>
Claude-Session: https://claude.ai/code/session_018cEtmP7qR8NtdHBxqnw8VA
</commit_message>
<xml_diff>
--- a/business-simulation/AeroForge_Final_Presentation.pptx
+++ b/business-simulation/AeroForge_Final_Presentation.pptx
@@ -5143,7 +5143,7 @@
                 </a:solidFill>
                 <a:latin typeface="Calibri"/>
               </a:rPr>
-              <a:t>From Q3: copy the revealed component matrices and leader ad structures. Bolt 53→77 (#1 Speed), ad 35→81 (best Speed ad), Summit #1 Mountain.</a:t>
+              <a:t>From Q3: copy the revealed component matrices and leader ad structures. Bolt 53→77 (#1 Speed), ad 35→80 (best Speed ad), Summit #1 Mountain (Q4).</a:t>
             </a:r>
           </a:p>
           <a:p>
@@ -5466,7 +5466,7 @@
                 </a:solidFill>
                 <a:latin typeface="Calibri"/>
               </a:rPr>
-              <a:t>A 35/100 ad starves a factory; below-market pay cut productivity to 68.6% and cost us 88 sales. We never lost money “in finance” — we lost it in marketing and HR first.</a:t>
+              <a:t>A 35/100 ad starves a factory; below-market pay cut productivity to 68.6% and helped cap our factory — 88 sales lost to stock-outs in Q4. We never lost money “in finance” — we lost it in marketing and HR first.</a:t>
             </a:r>
           </a:p>
           <a:p>
@@ -5931,7 +5931,7 @@
                 </a:solidFill>
                 <a:latin typeface="Calibri"/>
               </a:rPr>
-              <a:t>100% enriched-carbon range · #1-rated Mountain product · first profitable quarter (+$446k) · zero debt · #1 in class on Investment in Future</a:t>
+              <a:t>100% enriched-carbon range · first profitable quarter (+$446k) · zero debt · #1 in class on Investment in Future &amp; Financial Risk</a:t>
             </a:r>
           </a:p>
         </p:txBody>

</xml_diff>

<commit_message>
PPT final avec résultats Q6 réels (CA 3,0M, net +708k, judgments 87/83/78, cumul 0,703 dernier mais IF & FR n°1 classe) + captures résultats finaux
Co-Authored-By: Claude Fable 5 <noreply@anthropic.com>
Claude-Session: https://claude.ai/code/session_018cEtmP7qR8NtdHBxqnw8VA
</commit_message>
<xml_diff>
--- a/business-simulation/AeroForge_Final_Presentation.pptx
+++ b/business-simulation/AeroForge_Final_Presentation.pptx
@@ -662,7 +662,7 @@
           </a:p>
           <a:p>
             <a:r>
-              <a:t>Les faits, sans filtre. À gauche : notre Total Performance ×70 en trois trimestres — mais partie de si bas qu'au cumul nous finissons derniers : un index cumulatif ne pardonne pas un Q2 raté. À droite : le chiffre d'affaires a quasiment doublé chaque trimestre, de 226 k$ à 2,5 M$ projetés. Les deux creux de cash-flow en Q4-Q5 ne sont pas des pertes subies : c'est le déploiement volontaire des 2,5 M$ de capital-risque — R&amp;D, capacité, magasins — exactement comme promis au business plan. Résultat : premier trimestre rentable en Q6, +446 k$. Et côté Conscious Capitalism : seule entreprise jamais citée pour fuites toxiques, satisfaction employés 88 %, turnover divisé par trois. [Passe à Luna]</a:t>
+              <a:t>Les faits, sans filtre. À gauche : Total Performance ×269 en 4 trimestres (0,013 → 3,494) — mais partie de si bas qu'au cumul nous finissons derniers (0,70 vs 14,9 de moyenne) : un index cumulatif ne pardonne pas un Q2 raté. À droite : le CA a plus que doublé chaque trimestre, de 226 k$ au Q2 à 3,0 M$ au Q6. Les creux de cash-flow Q4-Q5 ne sont pas des pertes subies : c'est le déploiement volontaire des 2,5 M$ de capital-risque — R&amp;D, capacité, magasins — exactement comme promis au business plan. Et ça a payé : premier trimestre rentable au Q6 — +708 k$ de résultat net, 2 235 vélos vendus, demande de 3 318 qui dépasse même notre usine doublée. Côté Conscious Capitalism : seule entreprise jamais citée pour fuites toxiques, satisfaction employés 88 %, turnover divisé par trois. [Passe à Luna]</a:t>
             </a:r>
           </a:p>
         </p:txBody>
@@ -737,7 +737,7 @@
           </a:p>
           <a:p>
             <a:r>
-              <a:t>Pourquoi ce trou au Q2 ? Nous avons designé à l'intuition. Notre pub Speed utilisait des arguments Mountain — 35/100. Notre VTT avait un guidon « confort » : logique en apparence, faux dans les données — 62, sous le seuil de recommandation de la Customer Union. Résultat : demande étouffée pendant deux trimestres. Le déclic : à partir du Q3, plus aucune décision sans donnée. Toutes les études achetées, les matrices de composants copiées, nos pubs restructurées sur les meilleures. Regardez le graphe : chaque métrique corrigée a bougé — marque Bolt 53→77 numéro 1 Speed, pub 35→81 meilleure pub Speed, Summit numéro 1 Mountain, productivité +14 points, satisfaction vendeurs 88 %. La méthode a changé au milieu de la semaine : acheter la donnée, justifier chaque champ, tout vérifier. [Passe à Teysnim]</a:t>
+              <a:t>Pourquoi ce trou au Q2 ? Nous avons designé à l'intuition. Notre pub Speed utilisait des arguments Mountain — 35/100. Notre VTT avait un guidon « confort » : logique en apparence, faux dans les données — 62, sous le seuil de recommandation de la Customer Union. Résultat : demande étouffée pendant deux trimestres. Le déclic : à partir du Q3, plus aucune décision sans donnée. Toutes les études achetées, les matrices de composants copiées, nos pubs restructurées sur les meilleures, puis l'enriched carbon sur toute la gamme au Q6. Regardez le graphe : chaque métrique corrigée a bougé — Bolt 53→87, Summit 62→83 top-2 Mountain, Comfy 65→78 top-2 Recreation, pub 35→80, productivité +14 points. La méthode a changé au milieu de la semaine : acheter la donnée, justifier chaque champ, tout vérifier. [Passe à Teysnim]</a:t>
             </a:r>
           </a:p>
         </p:txBody>
@@ -887,7 +887,7 @@
           </a:p>
           <a:p>
             <a:r>
-              <a:t>Si nous recommencions : notre premier dollar irait à l'information. Toutes les études dès le Q2 — environ 45 000 $ — et designer depuis les matrices, jamais à l'instinct : un trimestre raté coûte cinquante fois le prix des études. Ce que nous ne referons jamais : lancer quoi que ce soit sans benchmark — une pub, un salaire, un prix. Le marché avait déjà publié la bonne réponse ; nous ne l'avions simplement pas achetée. Nous sortons du jeu avec une gamme 100 % enriched carbon, le produit Mountain le mieux noté, un premier trimestre rentable et zéro dette.</a:t>
+              <a:t>Si nous recommencions : notre premier dollar irait à l'information. Toutes les études dès le Q2 — environ 45 000 $ — et designer depuis les matrices, jamais à l'instinct : un trimestre raté coûte cinquante fois le prix des études. Ce que nous ne referons jamais : lancer quoi que ce soit sans benchmark — une pub, un salaire, un prix. Le marché avait déjà publié la bonne réponse ; nous ne l'avions simplement pas achetée. Nous sortons du jeu avec une gamme 100 % enriched carbon au top des classements, +708 k$ de résultat net au Q6, 2,06 M$ de trésorerie, zéro dette — et le titre de n°1 de la classe au cumul en Investment in Future et en Financial Risk.</a:t>
             </a:r>
           </a:p>
           <a:p/>
@@ -4810,7 +4810,7 @@
                 </a:solidFill>
                 <a:latin typeface="Calibri"/>
               </a:rPr>
-              <a:t>Cumulative scorecard: last. </a:t>
+              <a:t>Cumulative scorecard: last (0.70 vs class avg 14.9). </a:t>
             </a:r>
             <a:r>
               <a:rPr sz="1350" b="0" i="0">
@@ -4835,7 +4835,7 @@
                 </a:solidFill>
                 <a:latin typeface="Calibri"/>
               </a:rPr>
-              <a:t>Conscious scorecard: </a:t>
+              <a:t>Q6 finale: </a:t>
             </a:r>
             <a:r>
               <a:rPr sz="1350" b="0" i="0">
@@ -4844,7 +4844,32 @@
                 </a:solidFill>
                 <a:latin typeface="Calibri"/>
               </a:rPr>
-              <a:t>only firm never cited for toxic leaks · employee satisfaction 88% · turnover 32%→11% · reputation above class average.</a:t>
+              <a:t>2,235 bikes sold · $3.0M revenue · net income +$708k · demand (3,318) outgrew even our doubled factory.</a:t>
+            </a:r>
+          </a:p>
+          <a:p>
+            <a:pPr algn="l">
+              <a:spcAft>
+                <a:spcPts val="400"/>
+              </a:spcAft>
+            </a:pPr>
+            <a:r>
+              <a:rPr sz="1350" b="1" i="0">
+                <a:solidFill>
+                  <a:srgbClr val="0B0B0B"/>
+                </a:solidFill>
+                <a:latin typeface="Calibri"/>
+              </a:rPr>
+              <a:t>Conscious scorecard: </a:t>
+            </a:r>
+            <a:r>
+              <a:rPr sz="1350" b="0" i="0">
+                <a:solidFill>
+                  <a:srgbClr val="52514E"/>
+                </a:solidFill>
+                <a:latin typeface="Calibri"/>
+              </a:rPr>
+              <a:t>only firm never cited for toxic leaks · employee satisfaction 88% · turnover 32%→11%.</a:t>
             </a:r>
           </a:p>
         </p:txBody>
@@ -5143,7 +5168,7 @@
                 </a:solidFill>
                 <a:latin typeface="Calibri"/>
               </a:rPr>
-              <a:t>From Q3: copy the revealed component matrices and leader ad structures. Bolt 53→77 (#1 Speed), ad 35→80 (best Speed ad), Summit #1 Mountain (Q4).</a:t>
+              <a:t>From Q3: copy the revealed component matrices and leader ad structures — then enriched carbon across the range. By Q6: Bolt 53→87, Summit 62→83, Comfy 65→78. Every product top-tier.</a:t>
             </a:r>
           </a:p>
           <a:p>
@@ -5190,7 +5215,7 @@
         <p:spPr>
           <a:xfrm>
             <a:off x="5989320" y="1737360"/>
-            <a:ext cx="5760720" cy="3574265"/>
+            <a:ext cx="5760720" cy="3840480"/>
           </a:xfrm>
           <a:prstGeom prst="rect">
             <a:avLst/>
@@ -5931,7 +5956,7 @@
                 </a:solidFill>
                 <a:latin typeface="Calibri"/>
               </a:rPr>
-              <a:t>100% enriched-carbon range · first profitable quarter (+$446k) · zero debt · #1 in class on Investment in Future &amp; Financial Risk</a:t>
+              <a:t>100% enriched-carbon range · first profitable quarter (net +$708k) · $2.06M cash, zero debt · #1 in class on cumulative Investment in Future &amp; Financial Risk</a:t>
             </a:r>
           </a:p>
         </p:txBody>

</xml_diff>

<commit_message>
Audit final : corrections factuelles PPT + rapport (fuites toxiques 4/5, retained earnings -1,9M, ruptures Q3+, phase Q5)
Co-Authored-By: Claude Fable 5 <noreply@anthropic.com>
Claude-Session: https://claude.ai/code/session_018cEtmP7qR8NtdHBxqnw8VA
</commit_message>
<xml_diff>
--- a/business-simulation/AeroForge_Final_Presentation.pptx
+++ b/business-simulation/AeroForge_Final_Presentation.pptx
@@ -662,7 +662,7 @@
           </a:p>
           <a:p>
             <a:r>
-              <a:t>Les faits, sans filtre. À gauche : Total Performance ×269 en 4 trimestres (0,013 → 3,494) — mais partie de si bas qu'au cumul nous finissons derniers (0,70 vs 14,9 de moyenne) : un index cumulatif ne pardonne pas un Q2 raté. À droite : le CA a plus que doublé chaque trimestre, de 226 k$ au Q2 à 3,0 M$ au Q6. Les creux de cash-flow Q4-Q5 ne sont pas des pertes subies : c'est le déploiement volontaire des 2,5 M$ de capital-risque — R&amp;D, capacité, magasins — exactement comme promis au business plan. Et ça a payé : premier trimestre rentable au Q6 — +708 k$ de résultat net, 2 235 vélos vendus, demande de 3 318 qui dépasse même notre usine doublée. Côté Conscious Capitalism : seule entreprise jamais citée pour fuites toxiques, satisfaction employés 88 %, turnover divisé par trois. [Passe à Luna]</a:t>
+              <a:t>Les faits, sans filtre. À gauche : Total Performance ×269 en 4 trimestres (0,013 → 3,494) — mais partie de si bas qu'au cumul nous finissons derniers (0,70 vs 14,9 de moyenne) : un index cumulatif ne pardonne pas un Q2 raté. À droite : le CA a plus que doublé chaque trimestre, de 226 k$ au Q2 à 3,0 M$ au Q6. Les creux de cash-flow Q4-Q5 ne sont pas des pertes subies : c'est le déploiement volontaire des 2,5 M$ de capital-risque — R&amp;D, capacité, magasins — exactement comme promis au business plan. Et ça a payé : premier trimestre rentable au Q6 — +708 k$ de résultat net, 2 235 vélos vendus, demande de 3 318 qui dépasse même notre usine doublée. Côté Conscious Capitalism : jamais cités pour fuites toxiques (4 concurrents sur 5 l’ont été), satisfaction employés 88 %, turnover divisé par trois. [Passe à Luna]</a:t>
             </a:r>
           </a:p>
         </p:txBody>
@@ -4869,7 +4869,7 @@
                 </a:solidFill>
                 <a:latin typeface="Calibri"/>
               </a:rPr>
-              <a:t>only firm never cited for toxic leaks · employee satisfaction 88% · turnover 32%→11%.</a:t>
+              <a:t>never cited for toxic leaks · satisfaction 88% · turnover 32%→11%.</a:t>
             </a:r>
           </a:p>
         </p:txBody>

</xml_diff>